<commit_message>
Replace figure SVGs with PowerPoint exports of manually fixed slides
The reset symbols (XXX / ###) were repositioned by hand in
figures/Exp1_procedure.pptx (skewed to match the panel perspective,
which the scripted SVG text overlays did not do), and both slides were
re-exported to SVG from PowerPoint. Includes the updated .pptx so the
source stays in sync with the exported figures.

Note: caption text in these exports references Calibri, which is only
available where MS Office fonts are installed; renderers without it
(QuickLook, browsers) substitute a font with different metrics and the
caption spacing looks off. Displays correctly in PowerPoint/Word.

Co-Authored-By: Claude Fable 5 <noreply@anthropic.com>
</commit_message>
<xml_diff>
--- a/figures/Exp1_procedure.pptx
+++ b/figures/Exp1_procedure.pptx
@@ -1034,7 +1034,7 @@
           <a:p>
             <a:fld id="{9023F578-A551-491B-98ED-7220E4D0A93A}" type="datetimeFigureOut">
               <a:rPr lang="en-CH" smtClean="0"/>
-              <a:t>24/06/2023</a:t>
+              <a:t>8/10/26</a:t>
             </a:fld>
             <a:endParaRPr lang="en-CH"/>
           </a:p>
@@ -1234,7 +1234,7 @@
           <a:p>
             <a:fld id="{9023F578-A551-491B-98ED-7220E4D0A93A}" type="datetimeFigureOut">
               <a:rPr lang="en-CH" smtClean="0"/>
-              <a:t>24/06/2023</a:t>
+              <a:t>8/10/26</a:t>
             </a:fld>
             <a:endParaRPr lang="en-CH"/>
           </a:p>
@@ -1444,7 +1444,7 @@
           <a:p>
             <a:fld id="{9023F578-A551-491B-98ED-7220E4D0A93A}" type="datetimeFigureOut">
               <a:rPr lang="en-CH" smtClean="0"/>
-              <a:t>24/06/2023</a:t>
+              <a:t>8/10/26</a:t>
             </a:fld>
             <a:endParaRPr lang="en-CH"/>
           </a:p>
@@ -1644,7 +1644,7 @@
           <a:p>
             <a:fld id="{9023F578-A551-491B-98ED-7220E4D0A93A}" type="datetimeFigureOut">
               <a:rPr lang="en-CH" smtClean="0"/>
-              <a:t>24/06/2023</a:t>
+              <a:t>8/10/26</a:t>
             </a:fld>
             <a:endParaRPr lang="en-CH"/>
           </a:p>
@@ -1920,7 +1920,7 @@
           <a:p>
             <a:fld id="{9023F578-A551-491B-98ED-7220E4D0A93A}" type="datetimeFigureOut">
               <a:rPr lang="en-CH" smtClean="0"/>
-              <a:t>24/06/2023</a:t>
+              <a:t>8/10/26</a:t>
             </a:fld>
             <a:endParaRPr lang="en-CH"/>
           </a:p>
@@ -2188,7 +2188,7 @@
           <a:p>
             <a:fld id="{9023F578-A551-491B-98ED-7220E4D0A93A}" type="datetimeFigureOut">
               <a:rPr lang="en-CH" smtClean="0"/>
-              <a:t>24/06/2023</a:t>
+              <a:t>8/10/26</a:t>
             </a:fld>
             <a:endParaRPr lang="en-CH"/>
           </a:p>
@@ -2603,7 +2603,7 @@
           <a:p>
             <a:fld id="{9023F578-A551-491B-98ED-7220E4D0A93A}" type="datetimeFigureOut">
               <a:rPr lang="en-CH" smtClean="0"/>
-              <a:t>24/06/2023</a:t>
+              <a:t>8/10/26</a:t>
             </a:fld>
             <a:endParaRPr lang="en-CH"/>
           </a:p>
@@ -2745,7 +2745,7 @@
           <a:p>
             <a:fld id="{9023F578-A551-491B-98ED-7220E4D0A93A}" type="datetimeFigureOut">
               <a:rPr lang="en-CH" smtClean="0"/>
-              <a:t>24/06/2023</a:t>
+              <a:t>8/10/26</a:t>
             </a:fld>
             <a:endParaRPr lang="en-CH"/>
           </a:p>
@@ -2858,7 +2858,7 @@
           <a:p>
             <a:fld id="{9023F578-A551-491B-98ED-7220E4D0A93A}" type="datetimeFigureOut">
               <a:rPr lang="en-CH" smtClean="0"/>
-              <a:t>24/06/2023</a:t>
+              <a:t>8/10/26</a:t>
             </a:fld>
             <a:endParaRPr lang="en-CH"/>
           </a:p>
@@ -3171,7 +3171,7 @@
           <a:p>
             <a:fld id="{9023F578-A551-491B-98ED-7220E4D0A93A}" type="datetimeFigureOut">
               <a:rPr lang="en-CH" smtClean="0"/>
-              <a:t>24/06/2023</a:t>
+              <a:t>8/10/26</a:t>
             </a:fld>
             <a:endParaRPr lang="en-CH"/>
           </a:p>
@@ -3460,7 +3460,7 @@
           <a:p>
             <a:fld id="{9023F578-A551-491B-98ED-7220E4D0A93A}" type="datetimeFigureOut">
               <a:rPr lang="en-CH" smtClean="0"/>
-              <a:t>24/06/2023</a:t>
+              <a:t>8/10/26</a:t>
             </a:fld>
             <a:endParaRPr lang="en-CH"/>
           </a:p>
@@ -3703,7 +3703,7 @@
           <a:p>
             <a:fld id="{9023F578-A551-491B-98ED-7220E4D0A93A}" type="datetimeFigureOut">
               <a:rPr lang="en-CH" smtClean="0"/>
-              <a:t>24/06/2023</a:t>
+              <a:t>8/10/26</a:t>
             </a:fld>
             <a:endParaRPr lang="en-CH"/>
           </a:p>
@@ -5668,7 +5668,7 @@
                       <a:latin typeface="Arial" panose="020B0604020202020204" pitchFamily="34" charset="0"/>
                       <a:cs typeface="Arial" panose="020B0604020202020204" pitchFamily="34" charset="0"/>
                     </a:rPr>
-                    <a:t>X</a:t>
+                    <a:t>XXX</a:t>
                   </a:r>
                   <a:endParaRPr lang="en-CH" dirty="0">
                     <a:solidFill>
@@ -8627,7 +8627,7 @@
                   <a:latin typeface="Arial" panose="020B0604020202020204" pitchFamily="34" charset="0"/>
                   <a:cs typeface="Arial" panose="020B0604020202020204" pitchFamily="34" charset="0"/>
                 </a:rPr>
-                <a:t>X</a:t>
+                <a:t>###</a:t>
               </a:r>
               <a:endParaRPr lang="en-CH" dirty="0">
                 <a:solidFill>
@@ -8831,7 +8831,7 @@
           <p:spPr>
             <a:xfrm>
               <a:off x="4842440" y="3899238"/>
-              <a:ext cx="579005" cy="230832"/>
+              <a:ext cx="521297" cy="230832"/>
             </a:xfrm>
             <a:prstGeom prst="rect">
               <a:avLst/>
@@ -8850,7 +8850,7 @@
             <a:p>
               <a:r>
                 <a:rPr lang="en-US" sz="900" dirty="0"/>
-                <a:t>1000 </a:t>
+                <a:t>250 </a:t>
               </a:r>
               <a:r>
                 <a:rPr lang="en-US" sz="900" dirty="0" err="1"/>
@@ -9665,8 +9665,8 @@
           </p:nvCxnSpPr>
           <p:spPr>
             <a:xfrm>
-              <a:off x="5131943" y="4130070"/>
-              <a:ext cx="2960" cy="150249"/>
+              <a:off x="5103089" y="4130070"/>
+              <a:ext cx="31814" cy="150249"/>
             </a:xfrm>
             <a:prstGeom prst="line">
               <a:avLst/>

</xml_diff>

<commit_message>
Revert "Fix procedure figures: reset symbols and Exp 2 reset duration label (#6)"
This reverts commit 2d6af5203502ec436a026d743dd4df7d1f1090d6.
</commit_message>
<xml_diff>
--- a/figures/Exp1_procedure.pptx
+++ b/figures/Exp1_procedure.pptx
@@ -1034,7 +1034,7 @@
           <a:p>
             <a:fld id="{9023F578-A551-491B-98ED-7220E4D0A93A}" type="datetimeFigureOut">
               <a:rPr lang="en-CH" smtClean="0"/>
-              <a:t>8/10/26</a:t>
+              <a:t>24/06/2023</a:t>
             </a:fld>
             <a:endParaRPr lang="en-CH"/>
           </a:p>
@@ -1234,7 +1234,7 @@
           <a:p>
             <a:fld id="{9023F578-A551-491B-98ED-7220E4D0A93A}" type="datetimeFigureOut">
               <a:rPr lang="en-CH" smtClean="0"/>
-              <a:t>8/10/26</a:t>
+              <a:t>24/06/2023</a:t>
             </a:fld>
             <a:endParaRPr lang="en-CH"/>
           </a:p>
@@ -1444,7 +1444,7 @@
           <a:p>
             <a:fld id="{9023F578-A551-491B-98ED-7220E4D0A93A}" type="datetimeFigureOut">
               <a:rPr lang="en-CH" smtClean="0"/>
-              <a:t>8/10/26</a:t>
+              <a:t>24/06/2023</a:t>
             </a:fld>
             <a:endParaRPr lang="en-CH"/>
           </a:p>
@@ -1644,7 +1644,7 @@
           <a:p>
             <a:fld id="{9023F578-A551-491B-98ED-7220E4D0A93A}" type="datetimeFigureOut">
               <a:rPr lang="en-CH" smtClean="0"/>
-              <a:t>8/10/26</a:t>
+              <a:t>24/06/2023</a:t>
             </a:fld>
             <a:endParaRPr lang="en-CH"/>
           </a:p>
@@ -1920,7 +1920,7 @@
           <a:p>
             <a:fld id="{9023F578-A551-491B-98ED-7220E4D0A93A}" type="datetimeFigureOut">
               <a:rPr lang="en-CH" smtClean="0"/>
-              <a:t>8/10/26</a:t>
+              <a:t>24/06/2023</a:t>
             </a:fld>
             <a:endParaRPr lang="en-CH"/>
           </a:p>
@@ -2188,7 +2188,7 @@
           <a:p>
             <a:fld id="{9023F578-A551-491B-98ED-7220E4D0A93A}" type="datetimeFigureOut">
               <a:rPr lang="en-CH" smtClean="0"/>
-              <a:t>8/10/26</a:t>
+              <a:t>24/06/2023</a:t>
             </a:fld>
             <a:endParaRPr lang="en-CH"/>
           </a:p>
@@ -2603,7 +2603,7 @@
           <a:p>
             <a:fld id="{9023F578-A551-491B-98ED-7220E4D0A93A}" type="datetimeFigureOut">
               <a:rPr lang="en-CH" smtClean="0"/>
-              <a:t>8/10/26</a:t>
+              <a:t>24/06/2023</a:t>
             </a:fld>
             <a:endParaRPr lang="en-CH"/>
           </a:p>
@@ -2745,7 +2745,7 @@
           <a:p>
             <a:fld id="{9023F578-A551-491B-98ED-7220E4D0A93A}" type="datetimeFigureOut">
               <a:rPr lang="en-CH" smtClean="0"/>
-              <a:t>8/10/26</a:t>
+              <a:t>24/06/2023</a:t>
             </a:fld>
             <a:endParaRPr lang="en-CH"/>
           </a:p>
@@ -2858,7 +2858,7 @@
           <a:p>
             <a:fld id="{9023F578-A551-491B-98ED-7220E4D0A93A}" type="datetimeFigureOut">
               <a:rPr lang="en-CH" smtClean="0"/>
-              <a:t>8/10/26</a:t>
+              <a:t>24/06/2023</a:t>
             </a:fld>
             <a:endParaRPr lang="en-CH"/>
           </a:p>
@@ -3171,7 +3171,7 @@
           <a:p>
             <a:fld id="{9023F578-A551-491B-98ED-7220E4D0A93A}" type="datetimeFigureOut">
               <a:rPr lang="en-CH" smtClean="0"/>
-              <a:t>8/10/26</a:t>
+              <a:t>24/06/2023</a:t>
             </a:fld>
             <a:endParaRPr lang="en-CH"/>
           </a:p>
@@ -3460,7 +3460,7 @@
           <a:p>
             <a:fld id="{9023F578-A551-491B-98ED-7220E4D0A93A}" type="datetimeFigureOut">
               <a:rPr lang="en-CH" smtClean="0"/>
-              <a:t>8/10/26</a:t>
+              <a:t>24/06/2023</a:t>
             </a:fld>
             <a:endParaRPr lang="en-CH"/>
           </a:p>
@@ -3703,7 +3703,7 @@
           <a:p>
             <a:fld id="{9023F578-A551-491B-98ED-7220E4D0A93A}" type="datetimeFigureOut">
               <a:rPr lang="en-CH" smtClean="0"/>
-              <a:t>8/10/26</a:t>
+              <a:t>24/06/2023</a:t>
             </a:fld>
             <a:endParaRPr lang="en-CH"/>
           </a:p>
@@ -5668,7 +5668,7 @@
                       <a:latin typeface="Arial" panose="020B0604020202020204" pitchFamily="34" charset="0"/>
                       <a:cs typeface="Arial" panose="020B0604020202020204" pitchFamily="34" charset="0"/>
                     </a:rPr>
-                    <a:t>XXX</a:t>
+                    <a:t>X</a:t>
                   </a:r>
                   <a:endParaRPr lang="en-CH" dirty="0">
                     <a:solidFill>
@@ -8627,7 +8627,7 @@
                   <a:latin typeface="Arial" panose="020B0604020202020204" pitchFamily="34" charset="0"/>
                   <a:cs typeface="Arial" panose="020B0604020202020204" pitchFamily="34" charset="0"/>
                 </a:rPr>
-                <a:t>###</a:t>
+                <a:t>X</a:t>
               </a:r>
               <a:endParaRPr lang="en-CH" dirty="0">
                 <a:solidFill>
@@ -8831,7 +8831,7 @@
           <p:spPr>
             <a:xfrm>
               <a:off x="4842440" y="3899238"/>
-              <a:ext cx="521297" cy="230832"/>
+              <a:ext cx="579005" cy="230832"/>
             </a:xfrm>
             <a:prstGeom prst="rect">
               <a:avLst/>
@@ -8850,7 +8850,7 @@
             <a:p>
               <a:r>
                 <a:rPr lang="en-US" sz="900" dirty="0"/>
-                <a:t>250 </a:t>
+                <a:t>1000 </a:t>
               </a:r>
               <a:r>
                 <a:rPr lang="en-US" sz="900" dirty="0" err="1"/>
@@ -9665,8 +9665,8 @@
           </p:nvCxnSpPr>
           <p:spPr>
             <a:xfrm>
-              <a:off x="5103089" y="4130070"/>
-              <a:ext cx="31814" cy="150249"/>
+              <a:off x="5131943" y="4130070"/>
+              <a:ext cx="2960" cy="150249"/>
             </a:xfrm>
             <a:prstGeom prst="line">
               <a:avLst/>

</xml_diff>

<commit_message>
Re-add hand-corrected figure source pptx (XXX/### reset symbols)
This is the source of the reset panels grafted into the procedure
figure SVGs in #7; it was reverted from main along with #6.

Co-Authored-By: Claude Fable 5 <noreply@anthropic.com>
</commit_message>
<xml_diff>
--- a/figures/Exp1_procedure.pptx
+++ b/figures/Exp1_procedure.pptx
@@ -1034,7 +1034,7 @@
           <a:p>
             <a:fld id="{9023F578-A551-491B-98ED-7220E4D0A93A}" type="datetimeFigureOut">
               <a:rPr lang="en-CH" smtClean="0"/>
-              <a:t>24/06/2023</a:t>
+              <a:t>8/10/26</a:t>
             </a:fld>
             <a:endParaRPr lang="en-CH"/>
           </a:p>
@@ -1234,7 +1234,7 @@
           <a:p>
             <a:fld id="{9023F578-A551-491B-98ED-7220E4D0A93A}" type="datetimeFigureOut">
               <a:rPr lang="en-CH" smtClean="0"/>
-              <a:t>24/06/2023</a:t>
+              <a:t>8/10/26</a:t>
             </a:fld>
             <a:endParaRPr lang="en-CH"/>
           </a:p>
@@ -1444,7 +1444,7 @@
           <a:p>
             <a:fld id="{9023F578-A551-491B-98ED-7220E4D0A93A}" type="datetimeFigureOut">
               <a:rPr lang="en-CH" smtClean="0"/>
-              <a:t>24/06/2023</a:t>
+              <a:t>8/10/26</a:t>
             </a:fld>
             <a:endParaRPr lang="en-CH"/>
           </a:p>
@@ -1644,7 +1644,7 @@
           <a:p>
             <a:fld id="{9023F578-A551-491B-98ED-7220E4D0A93A}" type="datetimeFigureOut">
               <a:rPr lang="en-CH" smtClean="0"/>
-              <a:t>24/06/2023</a:t>
+              <a:t>8/10/26</a:t>
             </a:fld>
             <a:endParaRPr lang="en-CH"/>
           </a:p>
@@ -1920,7 +1920,7 @@
           <a:p>
             <a:fld id="{9023F578-A551-491B-98ED-7220E4D0A93A}" type="datetimeFigureOut">
               <a:rPr lang="en-CH" smtClean="0"/>
-              <a:t>24/06/2023</a:t>
+              <a:t>8/10/26</a:t>
             </a:fld>
             <a:endParaRPr lang="en-CH"/>
           </a:p>
@@ -2188,7 +2188,7 @@
           <a:p>
             <a:fld id="{9023F578-A551-491B-98ED-7220E4D0A93A}" type="datetimeFigureOut">
               <a:rPr lang="en-CH" smtClean="0"/>
-              <a:t>24/06/2023</a:t>
+              <a:t>8/10/26</a:t>
             </a:fld>
             <a:endParaRPr lang="en-CH"/>
           </a:p>
@@ -2603,7 +2603,7 @@
           <a:p>
             <a:fld id="{9023F578-A551-491B-98ED-7220E4D0A93A}" type="datetimeFigureOut">
               <a:rPr lang="en-CH" smtClean="0"/>
-              <a:t>24/06/2023</a:t>
+              <a:t>8/10/26</a:t>
             </a:fld>
             <a:endParaRPr lang="en-CH"/>
           </a:p>
@@ -2745,7 +2745,7 @@
           <a:p>
             <a:fld id="{9023F578-A551-491B-98ED-7220E4D0A93A}" type="datetimeFigureOut">
               <a:rPr lang="en-CH" smtClean="0"/>
-              <a:t>24/06/2023</a:t>
+              <a:t>8/10/26</a:t>
             </a:fld>
             <a:endParaRPr lang="en-CH"/>
           </a:p>
@@ -2858,7 +2858,7 @@
           <a:p>
             <a:fld id="{9023F578-A551-491B-98ED-7220E4D0A93A}" type="datetimeFigureOut">
               <a:rPr lang="en-CH" smtClean="0"/>
-              <a:t>24/06/2023</a:t>
+              <a:t>8/10/26</a:t>
             </a:fld>
             <a:endParaRPr lang="en-CH"/>
           </a:p>
@@ -3171,7 +3171,7 @@
           <a:p>
             <a:fld id="{9023F578-A551-491B-98ED-7220E4D0A93A}" type="datetimeFigureOut">
               <a:rPr lang="en-CH" smtClean="0"/>
-              <a:t>24/06/2023</a:t>
+              <a:t>8/10/26</a:t>
             </a:fld>
             <a:endParaRPr lang="en-CH"/>
           </a:p>
@@ -3460,7 +3460,7 @@
           <a:p>
             <a:fld id="{9023F578-A551-491B-98ED-7220E4D0A93A}" type="datetimeFigureOut">
               <a:rPr lang="en-CH" smtClean="0"/>
-              <a:t>24/06/2023</a:t>
+              <a:t>8/10/26</a:t>
             </a:fld>
             <a:endParaRPr lang="en-CH"/>
           </a:p>
@@ -3703,7 +3703,7 @@
           <a:p>
             <a:fld id="{9023F578-A551-491B-98ED-7220E4D0A93A}" type="datetimeFigureOut">
               <a:rPr lang="en-CH" smtClean="0"/>
-              <a:t>24/06/2023</a:t>
+              <a:t>8/10/26</a:t>
             </a:fld>
             <a:endParaRPr lang="en-CH"/>
           </a:p>
@@ -4134,7 +4134,7 @@
         </p:nvGrpSpPr>
         <p:grpSpPr>
           <a:xfrm>
-            <a:off x="2603018" y="206593"/>
+            <a:off x="2592969" y="216642"/>
             <a:ext cx="6718300" cy="5607251"/>
             <a:chOff x="2603018" y="206593"/>
             <a:chExt cx="6718300" cy="5607251"/>
@@ -5668,7 +5668,7 @@
                       <a:latin typeface="Arial" panose="020B0604020202020204" pitchFamily="34" charset="0"/>
                       <a:cs typeface="Arial" panose="020B0604020202020204" pitchFamily="34" charset="0"/>
                     </a:rPr>
-                    <a:t>X</a:t>
+                    <a:t>XXX</a:t>
                   </a:r>
                   <a:endParaRPr lang="en-CH" dirty="0">
                     <a:solidFill>
@@ -8627,7 +8627,7 @@
                   <a:latin typeface="Arial" panose="020B0604020202020204" pitchFamily="34" charset="0"/>
                   <a:cs typeface="Arial" panose="020B0604020202020204" pitchFamily="34" charset="0"/>
                 </a:rPr>
-                <a:t>X</a:t>
+                <a:t>###</a:t>
               </a:r>
               <a:endParaRPr lang="en-CH" dirty="0">
                 <a:solidFill>
@@ -8831,7 +8831,7 @@
           <p:spPr>
             <a:xfrm>
               <a:off x="4842440" y="3899238"/>
-              <a:ext cx="579005" cy="230832"/>
+              <a:ext cx="521297" cy="230832"/>
             </a:xfrm>
             <a:prstGeom prst="rect">
               <a:avLst/>
@@ -8850,7 +8850,7 @@
             <a:p>
               <a:r>
                 <a:rPr lang="en-US" sz="900" dirty="0"/>
-                <a:t>1000 </a:t>
+                <a:t>250 </a:t>
               </a:r>
               <a:r>
                 <a:rPr lang="en-US" sz="900" dirty="0" err="1"/>
@@ -9665,8 +9665,8 @@
           </p:nvCxnSpPr>
           <p:spPr>
             <a:xfrm>
-              <a:off x="5131943" y="4130070"/>
-              <a:ext cx="2960" cy="150249"/>
+              <a:off x="5103089" y="4130070"/>
+              <a:ext cx="31814" cy="150249"/>
             </a:xfrm>
             <a:prstGeom prst="line">
               <a:avLst/>

</xml_diff>